<commit_message>
fix: clarify 1500 MW stat as plant infrastructure supported
Update homepage, dossier preview, and brief PPT wording so the metric
reads as civil/infra support for a 1500 MW plant, not plant ownership.

Co-authored-by: nakshkanchan12 <nakshkanchan12@users.noreply.github.com>
</commit_message>
<xml_diff>
--- a/Baltej_Infra_Brief_Dossier.pptx
+++ b/Baltej_Infra_Brief_Dossier.pptx
@@ -4117,7 +4117,7 @@
         <p:spPr>
           <a:xfrm>
             <a:off x="731520" y="2377440"/>
-            <a:ext cx="2468880" cy="2194560"/>
+            <a:ext cx="2468880" cy="2377440"/>
           </a:xfrm>
           <a:prstGeom prst="rect">
             <a:avLst/>
@@ -4160,7 +4160,7 @@
         <p:spPr>
           <a:xfrm>
             <a:off x="914400" y="2651760"/>
-            <a:ext cx="2103120" cy="822960"/>
+            <a:ext cx="2103120" cy="731520"/>
           </a:xfrm>
           <a:prstGeom prst="rect">
             <a:avLst/>
@@ -4194,8 +4194,8 @@
         </p:nvSpPr>
         <p:spPr>
           <a:xfrm>
-            <a:off x="914400" y="3566160"/>
-            <a:ext cx="2103120" cy="640080"/>
+            <a:off x="914400" y="3520440"/>
+            <a:ext cx="2103120" cy="914400"/>
           </a:xfrm>
           <a:prstGeom prst="rect">
             <a:avLst/>
@@ -4210,7 +4210,7 @@
           <a:p>
             <a:pPr algn="l"/>
             <a:r>
-              <a:rPr sz="1600" b="0">
+              <a:rPr sz="1500" b="0">
                 <a:solidFill>
                   <a:srgbClr val="9AA3AD"/>
                 </a:solidFill>
@@ -4230,7 +4230,7 @@
         <p:spPr>
           <a:xfrm>
             <a:off x="3474720" y="2377440"/>
-            <a:ext cx="2468880" cy="2194560"/>
+            <a:ext cx="2468880" cy="2377440"/>
           </a:xfrm>
           <a:prstGeom prst="rect">
             <a:avLst/>
@@ -4273,7 +4273,7 @@
         <p:spPr>
           <a:xfrm>
             <a:off x="3657600" y="2651760"/>
-            <a:ext cx="2103120" cy="822960"/>
+            <a:ext cx="2103120" cy="731520"/>
           </a:xfrm>
           <a:prstGeom prst="rect">
             <a:avLst/>
@@ -4307,8 +4307,8 @@
         </p:nvSpPr>
         <p:spPr>
           <a:xfrm>
-            <a:off x="3657600" y="3566160"/>
-            <a:ext cx="2103120" cy="640080"/>
+            <a:off x="3657600" y="3520440"/>
+            <a:ext cx="2103120" cy="914400"/>
           </a:xfrm>
           <a:prstGeom prst="rect">
             <a:avLst/>
@@ -4323,7 +4323,7 @@
           <a:p>
             <a:pPr algn="l"/>
             <a:r>
-              <a:rPr sz="1600" b="0">
+              <a:rPr sz="1500" b="0">
                 <a:solidFill>
                   <a:srgbClr val="9AA3AD"/>
                 </a:solidFill>
@@ -4343,7 +4343,7 @@
         <p:spPr>
           <a:xfrm>
             <a:off x="6217920" y="2377440"/>
-            <a:ext cx="2468880" cy="2194560"/>
+            <a:ext cx="2468880" cy="2377440"/>
           </a:xfrm>
           <a:prstGeom prst="rect">
             <a:avLst/>
@@ -4386,7 +4386,7 @@
         <p:spPr>
           <a:xfrm>
             <a:off x="6400800" y="2651760"/>
-            <a:ext cx="2103120" cy="822960"/>
+            <a:ext cx="2103120" cy="731520"/>
           </a:xfrm>
           <a:prstGeom prst="rect">
             <a:avLst/>
@@ -4420,8 +4420,8 @@
         </p:nvSpPr>
         <p:spPr>
           <a:xfrm>
-            <a:off x="6400800" y="3566160"/>
-            <a:ext cx="2103120" cy="640080"/>
+            <a:off x="6400800" y="3520440"/>
+            <a:ext cx="2103120" cy="914400"/>
           </a:xfrm>
           <a:prstGeom prst="rect">
             <a:avLst/>
@@ -4436,13 +4436,25 @@
           <a:p>
             <a:pPr algn="l"/>
             <a:r>
-              <a:rPr sz="1600" b="0">
+              <a:rPr sz="1500" b="0">
                 <a:solidFill>
                   <a:srgbClr val="9AA3AD"/>
                 </a:solidFill>
                 <a:latin typeface="Arial"/>
               </a:rPr>
               <a:t>MW plant infra</a:t>
+            </a:r>
+          </a:p>
+          <a:p>
+            <a:pPr algn="l"/>
+            <a:r>
+              <a:rPr sz="1500" b="0">
+                <a:solidFill>
+                  <a:srgbClr val="9AA3AD"/>
+                </a:solidFill>
+                <a:latin typeface="Arial"/>
+              </a:rPr>
+              <a:t>supported</a:t>
             </a:r>
           </a:p>
         </p:txBody>
@@ -4456,7 +4468,7 @@
         <p:spPr>
           <a:xfrm>
             <a:off x="8961120" y="2377440"/>
-            <a:ext cx="2468880" cy="2194560"/>
+            <a:ext cx="2468880" cy="2377440"/>
           </a:xfrm>
           <a:prstGeom prst="rect">
             <a:avLst/>
@@ -4499,7 +4511,7 @@
         <p:spPr>
           <a:xfrm>
             <a:off x="9144000" y="2651760"/>
-            <a:ext cx="2103120" cy="822960"/>
+            <a:ext cx="2103120" cy="731520"/>
           </a:xfrm>
           <a:prstGeom prst="rect">
             <a:avLst/>
@@ -4533,8 +4545,8 @@
         </p:nvSpPr>
         <p:spPr>
           <a:xfrm>
-            <a:off x="9144000" y="3566160"/>
-            <a:ext cx="2103120" cy="640080"/>
+            <a:off x="9144000" y="3520440"/>
+            <a:ext cx="2103120" cy="914400"/>
           </a:xfrm>
           <a:prstGeom prst="rect">
             <a:avLst/>
@@ -4549,7 +4561,7 @@
           <a:p>
             <a:pPr algn="l"/>
             <a:r>
-              <a:rPr sz="1600" b="0">
+              <a:rPr sz="1500" b="0">
                 <a:solidFill>
                   <a:srgbClr val="9AA3AD"/>
                 </a:solidFill>
@@ -5023,7 +5035,7 @@
                 </a:solidFill>
                 <a:latin typeface="Arial"/>
               </a:rPr>
-              <a:t>• Industrial / plant civil packages for power and related infra</a:t>
+              <a:t>• Civil infrastructure supporting power-plant and industrial projects</a:t>
             </a:r>
           </a:p>
           <a:p>

</xml_diff>

<commit_message>
feat: show client logos on dossier Trusted By slide
Replace the text client list in the brief dossier with a logo grid,
embed the same logos in the PPTX, and use local NHAI/NHIT assets on the
homepage carousel for offline-friendly loading.

Co-authored-by: nakshkanchan12 <nakshkanchan12@users.noreply.github.com>
</commit_message>
<xml_diff>
--- a/Baltej_Infra_Brief_Dossier.pptx
+++ b/Baltej_Infra_Brief_Dossier.pptx
@@ -4705,123 +4705,607 @@
       </p:sp>
       <p:sp>
         <p:nvSpPr>
-          <p:cNvPr id="5" name="TextBox 4"/>
-          <p:cNvSpPr txBox="1"/>
-          <p:nvPr/>
-        </p:nvSpPr>
-        <p:spPr>
-          <a:xfrm>
-            <a:off x="731520" y="2103120"/>
-            <a:ext cx="10058400" cy="3657600"/>
-          </a:xfrm>
-          <a:prstGeom prst="rect">
-            <a:avLst/>
-          </a:prstGeom>
-          <a:noFill/>
-        </p:spPr>
-        <p:txBody>
-          <a:bodyPr wrap="square">
-            <a:spAutoFit/>
-          </a:bodyPr>
-          <a:lstStyle/>
-          <a:p>
-            <a:pPr algn="l">
-              <a:spcAft>
-                <a:spcPts val="800"/>
-              </a:spcAft>
-            </a:pPr>
-            <a:r>
-              <a:rPr sz="1800" b="0">
-                <a:solidFill>
-                  <a:srgbClr val="9AA3AD"/>
-                </a:solidFill>
-                <a:latin typeface="Arial"/>
-              </a:rPr>
-              <a:t>•  NHAI — National Highways Authority of India</a:t>
-            </a:r>
-          </a:p>
-          <a:p>
-            <a:pPr algn="l">
-              <a:spcAft>
-                <a:spcPts val="800"/>
-              </a:spcAft>
-            </a:pPr>
-            <a:r>
-              <a:rPr sz="1800" b="0">
-                <a:solidFill>
-                  <a:srgbClr val="9AA3AD"/>
-                </a:solidFill>
-                <a:latin typeface="Arial"/>
-              </a:rPr>
-              <a:t>•  SJVN Limited</a:t>
-            </a:r>
-          </a:p>
-          <a:p>
-            <a:pPr algn="l">
-              <a:spcAft>
-                <a:spcPts val="800"/>
-              </a:spcAft>
-            </a:pPr>
-            <a:r>
-              <a:rPr sz="1800" b="0">
-                <a:solidFill>
-                  <a:srgbClr val="9AA3AD"/>
-                </a:solidFill>
-                <a:latin typeface="Arial"/>
-              </a:rPr>
-              <a:t>•  NHLML — National Highways Logistics Management Limited</a:t>
-            </a:r>
-          </a:p>
-          <a:p>
-            <a:pPr algn="l">
-              <a:spcAft>
-                <a:spcPts val="800"/>
-              </a:spcAft>
-            </a:pPr>
-            <a:r>
-              <a:rPr sz="1800" b="0">
-                <a:solidFill>
-                  <a:srgbClr val="9AA3AD"/>
-                </a:solidFill>
-                <a:latin typeface="Arial"/>
-              </a:rPr>
-              <a:t>•  Airports Authority of India (AAI)</a:t>
-            </a:r>
-          </a:p>
-          <a:p>
-            <a:pPr algn="l">
-              <a:spcAft>
-                <a:spcPts val="800"/>
-              </a:spcAft>
-            </a:pPr>
-            <a:r>
-              <a:rPr sz="1800" b="0">
-                <a:solidFill>
-                  <a:srgbClr val="9AA3AD"/>
-                </a:solidFill>
-                <a:latin typeface="Arial"/>
-              </a:rPr>
-              <a:t>•  East Central Railway</a:t>
-            </a:r>
-          </a:p>
-          <a:p>
-            <a:pPr algn="l">
-              <a:spcAft>
-                <a:spcPts val="800"/>
-              </a:spcAft>
-            </a:pPr>
-            <a:r>
-              <a:rPr sz="1800" b="0">
-                <a:solidFill>
-                  <a:srgbClr val="9AA3AD"/>
-                </a:solidFill>
-                <a:latin typeface="Arial"/>
-              </a:rPr>
-              <a:t>•  GR Infraprojects · NHIT · MVD · Mohan Mutha · and others</a:t>
-            </a:r>
-          </a:p>
-        </p:txBody>
-      </p:sp>
+          <p:cNvPr id="5" name="Rectangle 4"/>
+          <p:cNvSpPr/>
+          <p:nvPr/>
+        </p:nvSpPr>
+        <p:spPr>
+          <a:xfrm>
+            <a:off x="822960" y="2011680"/>
+            <a:ext cx="3291840" cy="1051560"/>
+          </a:xfrm>
+          <a:prstGeom prst="rect">
+            <a:avLst/>
+          </a:prstGeom>
+          <a:solidFill>
+            <a:srgbClr val="FFFFFF"/>
+          </a:solidFill>
+          <a:ln>
+            <a:noFill/>
+          </a:ln>
+        </p:spPr>
+        <p:style>
+          <a:lnRef idx="1">
+            <a:schemeClr val="accent1"/>
+          </a:lnRef>
+          <a:fillRef idx="3">
+            <a:schemeClr val="accent1"/>
+          </a:fillRef>
+          <a:effectRef idx="2">
+            <a:schemeClr val="accent1"/>
+          </a:effectRef>
+          <a:fontRef idx="minor">
+            <a:schemeClr val="lt1"/>
+          </a:fontRef>
+        </p:style>
+        <p:txBody>
+          <a:bodyPr rtlCol="0" anchor="ctr"/>
+          <a:lstStyle/>
+          <a:p>
+            <a:pPr algn="ctr"/>
+          </a:p>
+        </p:txBody>
+      </p:sp>
+      <p:pic>
+        <p:nvPicPr>
+          <p:cNvPr id="6" name="Picture 5" descr="logo-nhai.png"/>
+          <p:cNvPicPr>
+            <a:picLocks noChangeAspect="1"/>
+          </p:cNvPicPr>
+          <p:nvPr/>
+        </p:nvPicPr>
+        <p:blipFill>
+          <a:blip r:embed="rId2"/>
+          <a:stretch>
+            <a:fillRect/>
+          </a:stretch>
+        </p:blipFill>
+        <p:spPr>
+          <a:xfrm>
+            <a:off x="1143000" y="2212848"/>
+            <a:ext cx="3528646" cy="640080"/>
+          </a:xfrm>
+          <a:prstGeom prst="rect">
+            <a:avLst/>
+          </a:prstGeom>
+        </p:spPr>
+      </p:pic>
+      <p:sp>
+        <p:nvSpPr>
+          <p:cNvPr id="7" name="Rectangle 6"/>
+          <p:cNvSpPr/>
+          <p:nvPr/>
+        </p:nvSpPr>
+        <p:spPr>
+          <a:xfrm>
+            <a:off x="4434840" y="2011680"/>
+            <a:ext cx="3291840" cy="1051560"/>
+          </a:xfrm>
+          <a:prstGeom prst="rect">
+            <a:avLst/>
+          </a:prstGeom>
+          <a:solidFill>
+            <a:srgbClr val="FFFFFF"/>
+          </a:solidFill>
+          <a:ln>
+            <a:noFill/>
+          </a:ln>
+        </p:spPr>
+        <p:style>
+          <a:lnRef idx="1">
+            <a:schemeClr val="accent1"/>
+          </a:lnRef>
+          <a:fillRef idx="3">
+            <a:schemeClr val="accent1"/>
+          </a:fillRef>
+          <a:effectRef idx="2">
+            <a:schemeClr val="accent1"/>
+          </a:effectRef>
+          <a:fontRef idx="minor">
+            <a:schemeClr val="lt1"/>
+          </a:fontRef>
+        </p:style>
+        <p:txBody>
+          <a:bodyPr rtlCol="0" anchor="ctr"/>
+          <a:lstStyle/>
+          <a:p>
+            <a:pPr algn="ctr"/>
+          </a:p>
+        </p:txBody>
+      </p:sp>
+      <p:pic>
+        <p:nvPicPr>
+          <p:cNvPr id="8" name="Picture 7" descr="sjvn-logo.png"/>
+          <p:cNvPicPr>
+            <a:picLocks noChangeAspect="1"/>
+          </p:cNvPicPr>
+          <p:nvPr/>
+        </p:nvPicPr>
+        <p:blipFill>
+          <a:blip r:embed="rId3"/>
+          <a:stretch>
+            <a:fillRect/>
+          </a:stretch>
+        </p:blipFill>
+        <p:spPr>
+          <a:xfrm>
+            <a:off x="4754880" y="2212848"/>
+            <a:ext cx="423333" cy="640080"/>
+          </a:xfrm>
+          <a:prstGeom prst="rect">
+            <a:avLst/>
+          </a:prstGeom>
+        </p:spPr>
+      </p:pic>
+      <p:sp>
+        <p:nvSpPr>
+          <p:cNvPr id="9" name="Rectangle 8"/>
+          <p:cNvSpPr/>
+          <p:nvPr/>
+        </p:nvSpPr>
+        <p:spPr>
+          <a:xfrm>
+            <a:off x="8046720" y="2011680"/>
+            <a:ext cx="3291840" cy="1051560"/>
+          </a:xfrm>
+          <a:prstGeom prst="rect">
+            <a:avLst/>
+          </a:prstGeom>
+          <a:solidFill>
+            <a:srgbClr val="FFFFFF"/>
+          </a:solidFill>
+          <a:ln>
+            <a:noFill/>
+          </a:ln>
+        </p:spPr>
+        <p:style>
+          <a:lnRef idx="1">
+            <a:schemeClr val="accent1"/>
+          </a:lnRef>
+          <a:fillRef idx="3">
+            <a:schemeClr val="accent1"/>
+          </a:fillRef>
+          <a:effectRef idx="2">
+            <a:schemeClr val="accent1"/>
+          </a:effectRef>
+          <a:fontRef idx="minor">
+            <a:schemeClr val="lt1"/>
+          </a:fontRef>
+        </p:style>
+        <p:txBody>
+          <a:bodyPr rtlCol="0" anchor="ctr"/>
+          <a:lstStyle/>
+          <a:p>
+            <a:pPr algn="ctr"/>
+          </a:p>
+        </p:txBody>
+      </p:sp>
+      <p:pic>
+        <p:nvPicPr>
+          <p:cNvPr id="10" name="Picture 9" descr="logo-nhlml.jpg"/>
+          <p:cNvPicPr>
+            <a:picLocks noChangeAspect="1"/>
+          </p:cNvPicPr>
+          <p:nvPr/>
+        </p:nvPicPr>
+        <p:blipFill>
+          <a:blip r:embed="rId4"/>
+          <a:stretch>
+            <a:fillRect/>
+          </a:stretch>
+        </p:blipFill>
+        <p:spPr>
+          <a:xfrm>
+            <a:off x="8366760" y="2212848"/>
+            <a:ext cx="640080" cy="640080"/>
+          </a:xfrm>
+          <a:prstGeom prst="rect">
+            <a:avLst/>
+          </a:prstGeom>
+        </p:spPr>
+      </p:pic>
+      <p:sp>
+        <p:nvSpPr>
+          <p:cNvPr id="11" name="Rectangle 10"/>
+          <p:cNvSpPr/>
+          <p:nvPr/>
+        </p:nvSpPr>
+        <p:spPr>
+          <a:xfrm>
+            <a:off x="822960" y="3319272"/>
+            <a:ext cx="3291840" cy="1051560"/>
+          </a:xfrm>
+          <a:prstGeom prst="rect">
+            <a:avLst/>
+          </a:prstGeom>
+          <a:solidFill>
+            <a:srgbClr val="FFFFFF"/>
+          </a:solidFill>
+          <a:ln>
+            <a:noFill/>
+          </a:ln>
+        </p:spPr>
+        <p:style>
+          <a:lnRef idx="1">
+            <a:schemeClr val="accent1"/>
+          </a:lnRef>
+          <a:fillRef idx="3">
+            <a:schemeClr val="accent1"/>
+          </a:fillRef>
+          <a:effectRef idx="2">
+            <a:schemeClr val="accent1"/>
+          </a:effectRef>
+          <a:fontRef idx="minor">
+            <a:schemeClr val="lt1"/>
+          </a:fontRef>
+        </p:style>
+        <p:txBody>
+          <a:bodyPr rtlCol="0" anchor="ctr"/>
+          <a:lstStyle/>
+          <a:p>
+            <a:pPr algn="ctr"/>
+          </a:p>
+        </p:txBody>
+      </p:sp>
+      <p:pic>
+        <p:nvPicPr>
+          <p:cNvPr id="12" name="Picture 11" descr="logo-aai.png"/>
+          <p:cNvPicPr>
+            <a:picLocks noChangeAspect="1"/>
+          </p:cNvPicPr>
+          <p:nvPr/>
+        </p:nvPicPr>
+        <p:blipFill>
+          <a:blip r:embed="rId5"/>
+          <a:stretch>
+            <a:fillRect/>
+          </a:stretch>
+        </p:blipFill>
+        <p:spPr>
+          <a:xfrm>
+            <a:off x="1143000" y="3520440"/>
+            <a:ext cx="830580" cy="640080"/>
+          </a:xfrm>
+          <a:prstGeom prst="rect">
+            <a:avLst/>
+          </a:prstGeom>
+        </p:spPr>
+      </p:pic>
+      <p:sp>
+        <p:nvSpPr>
+          <p:cNvPr id="13" name="Rectangle 12"/>
+          <p:cNvSpPr/>
+          <p:nvPr/>
+        </p:nvSpPr>
+        <p:spPr>
+          <a:xfrm>
+            <a:off x="4434840" y="3319272"/>
+            <a:ext cx="3291840" cy="1051560"/>
+          </a:xfrm>
+          <a:prstGeom prst="rect">
+            <a:avLst/>
+          </a:prstGeom>
+          <a:solidFill>
+            <a:srgbClr val="FFFFFF"/>
+          </a:solidFill>
+          <a:ln>
+            <a:noFill/>
+          </a:ln>
+        </p:spPr>
+        <p:style>
+          <a:lnRef idx="1">
+            <a:schemeClr val="accent1"/>
+          </a:lnRef>
+          <a:fillRef idx="3">
+            <a:schemeClr val="accent1"/>
+          </a:fillRef>
+          <a:effectRef idx="2">
+            <a:schemeClr val="accent1"/>
+          </a:effectRef>
+          <a:fontRef idx="minor">
+            <a:schemeClr val="lt1"/>
+          </a:fontRef>
+        </p:style>
+        <p:txBody>
+          <a:bodyPr rtlCol="0" anchor="ctr"/>
+          <a:lstStyle/>
+          <a:p>
+            <a:pPr algn="ctr"/>
+          </a:p>
+        </p:txBody>
+      </p:sp>
+      <p:pic>
+        <p:nvPicPr>
+          <p:cNvPr id="14" name="Picture 13" descr="logo-ecr.jpg"/>
+          <p:cNvPicPr>
+            <a:picLocks noChangeAspect="1"/>
+          </p:cNvPicPr>
+          <p:nvPr/>
+        </p:nvPicPr>
+        <p:blipFill>
+          <a:blip r:embed="rId6"/>
+          <a:stretch>
+            <a:fillRect/>
+          </a:stretch>
+        </p:blipFill>
+        <p:spPr>
+          <a:xfrm>
+            <a:off x="4754880" y="3520440"/>
+            <a:ext cx="957913" cy="640080"/>
+          </a:xfrm>
+          <a:prstGeom prst="rect">
+            <a:avLst/>
+          </a:prstGeom>
+        </p:spPr>
+      </p:pic>
+      <p:sp>
+        <p:nvSpPr>
+          <p:cNvPr id="15" name="Rectangle 14"/>
+          <p:cNvSpPr/>
+          <p:nvPr/>
+        </p:nvSpPr>
+        <p:spPr>
+          <a:xfrm>
+            <a:off x="8046720" y="3319272"/>
+            <a:ext cx="3291840" cy="1051560"/>
+          </a:xfrm>
+          <a:prstGeom prst="rect">
+            <a:avLst/>
+          </a:prstGeom>
+          <a:solidFill>
+            <a:srgbClr val="FFFFFF"/>
+          </a:solidFill>
+          <a:ln>
+            <a:noFill/>
+          </a:ln>
+        </p:spPr>
+        <p:style>
+          <a:lnRef idx="1">
+            <a:schemeClr val="accent1"/>
+          </a:lnRef>
+          <a:fillRef idx="3">
+            <a:schemeClr val="accent1"/>
+          </a:fillRef>
+          <a:effectRef idx="2">
+            <a:schemeClr val="accent1"/>
+          </a:effectRef>
+          <a:fontRef idx="minor">
+            <a:schemeClr val="lt1"/>
+          </a:fontRef>
+        </p:style>
+        <p:txBody>
+          <a:bodyPr rtlCol="0" anchor="ctr"/>
+          <a:lstStyle/>
+          <a:p>
+            <a:pPr algn="ctr"/>
+          </a:p>
+        </p:txBody>
+      </p:sp>
+      <p:pic>
+        <p:nvPicPr>
+          <p:cNvPr id="16" name="Picture 15" descr="logo-gril.png"/>
+          <p:cNvPicPr>
+            <a:picLocks noChangeAspect="1"/>
+          </p:cNvPicPr>
+          <p:nvPr/>
+        </p:nvPicPr>
+        <p:blipFill>
+          <a:blip r:embed="rId7"/>
+          <a:stretch>
+            <a:fillRect/>
+          </a:stretch>
+        </p:blipFill>
+        <p:spPr>
+          <a:xfrm>
+            <a:off x="8366760" y="3520440"/>
+            <a:ext cx="1020938" cy="640080"/>
+          </a:xfrm>
+          <a:prstGeom prst="rect">
+            <a:avLst/>
+          </a:prstGeom>
+        </p:spPr>
+      </p:pic>
+      <p:sp>
+        <p:nvSpPr>
+          <p:cNvPr id="17" name="Rectangle 16"/>
+          <p:cNvSpPr/>
+          <p:nvPr/>
+        </p:nvSpPr>
+        <p:spPr>
+          <a:xfrm>
+            <a:off x="822960" y="4626864"/>
+            <a:ext cx="3291840" cy="1051560"/>
+          </a:xfrm>
+          <a:prstGeom prst="rect">
+            <a:avLst/>
+          </a:prstGeom>
+          <a:solidFill>
+            <a:srgbClr val="FFFFFF"/>
+          </a:solidFill>
+          <a:ln>
+            <a:noFill/>
+          </a:ln>
+        </p:spPr>
+        <p:style>
+          <a:lnRef idx="1">
+            <a:schemeClr val="accent1"/>
+          </a:lnRef>
+          <a:fillRef idx="3">
+            <a:schemeClr val="accent1"/>
+          </a:fillRef>
+          <a:effectRef idx="2">
+            <a:schemeClr val="accent1"/>
+          </a:effectRef>
+          <a:fontRef idx="minor">
+            <a:schemeClr val="lt1"/>
+          </a:fontRef>
+        </p:style>
+        <p:txBody>
+          <a:bodyPr rtlCol="0" anchor="ctr"/>
+          <a:lstStyle/>
+          <a:p>
+            <a:pPr algn="ctr"/>
+          </a:p>
+        </p:txBody>
+      </p:sp>
+      <p:pic>
+        <p:nvPicPr>
+          <p:cNvPr id="18" name="Picture 17" descr="logo-nhit.png"/>
+          <p:cNvPicPr>
+            <a:picLocks noChangeAspect="1"/>
+          </p:cNvPicPr>
+          <p:nvPr/>
+        </p:nvPicPr>
+        <p:blipFill>
+          <a:blip r:embed="rId8"/>
+          <a:stretch>
+            <a:fillRect/>
+          </a:stretch>
+        </p:blipFill>
+        <p:spPr>
+          <a:xfrm>
+            <a:off x="1143000" y="4828032"/>
+            <a:ext cx="1573967" cy="640080"/>
+          </a:xfrm>
+          <a:prstGeom prst="rect">
+            <a:avLst/>
+          </a:prstGeom>
+        </p:spPr>
+      </p:pic>
+      <p:sp>
+        <p:nvSpPr>
+          <p:cNvPr id="19" name="Rectangle 18"/>
+          <p:cNvSpPr/>
+          <p:nvPr/>
+        </p:nvSpPr>
+        <p:spPr>
+          <a:xfrm>
+            <a:off x="4434840" y="4626864"/>
+            <a:ext cx="3291840" cy="1051560"/>
+          </a:xfrm>
+          <a:prstGeom prst="rect">
+            <a:avLst/>
+          </a:prstGeom>
+          <a:solidFill>
+            <a:srgbClr val="FFFFFF"/>
+          </a:solidFill>
+          <a:ln>
+            <a:noFill/>
+          </a:ln>
+        </p:spPr>
+        <p:style>
+          <a:lnRef idx="1">
+            <a:schemeClr val="accent1"/>
+          </a:lnRef>
+          <a:fillRef idx="3">
+            <a:schemeClr val="accent1"/>
+          </a:fillRef>
+          <a:effectRef idx="2">
+            <a:schemeClr val="accent1"/>
+          </a:effectRef>
+          <a:fontRef idx="minor">
+            <a:schemeClr val="lt1"/>
+          </a:fontRef>
+        </p:style>
+        <p:txBody>
+          <a:bodyPr rtlCol="0" anchor="ctr"/>
+          <a:lstStyle/>
+          <a:p>
+            <a:pPr algn="ctr"/>
+          </a:p>
+        </p:txBody>
+      </p:sp>
+      <p:pic>
+        <p:nvPicPr>
+          <p:cNvPr id="20" name="Picture 19" descr="mvd-logo.jpg"/>
+          <p:cNvPicPr>
+            <a:picLocks noChangeAspect="1"/>
+          </p:cNvPicPr>
+          <p:nvPr/>
+        </p:nvPicPr>
+        <p:blipFill>
+          <a:blip r:embed="rId9"/>
+          <a:stretch>
+            <a:fillRect/>
+          </a:stretch>
+        </p:blipFill>
+        <p:spPr>
+          <a:xfrm>
+            <a:off x="4754880" y="4828032"/>
+            <a:ext cx="640080" cy="640080"/>
+          </a:xfrm>
+          <a:prstGeom prst="rect">
+            <a:avLst/>
+          </a:prstGeom>
+        </p:spPr>
+      </p:pic>
+      <p:sp>
+        <p:nvSpPr>
+          <p:cNvPr id="21" name="Rectangle 20"/>
+          <p:cNvSpPr/>
+          <p:nvPr/>
+        </p:nvSpPr>
+        <p:spPr>
+          <a:xfrm>
+            <a:off x="8046720" y="4626864"/>
+            <a:ext cx="3291840" cy="1051560"/>
+          </a:xfrm>
+          <a:prstGeom prst="rect">
+            <a:avLst/>
+          </a:prstGeom>
+          <a:solidFill>
+            <a:srgbClr val="FFFFFF"/>
+          </a:solidFill>
+          <a:ln>
+            <a:noFill/>
+          </a:ln>
+        </p:spPr>
+        <p:style>
+          <a:lnRef idx="1">
+            <a:schemeClr val="accent1"/>
+          </a:lnRef>
+          <a:fillRef idx="3">
+            <a:schemeClr val="accent1"/>
+          </a:fillRef>
+          <a:effectRef idx="2">
+            <a:schemeClr val="accent1"/>
+          </a:effectRef>
+          <a:fontRef idx="minor">
+            <a:schemeClr val="lt1"/>
+          </a:fontRef>
+        </p:style>
+        <p:txBody>
+          <a:bodyPr rtlCol="0" anchor="ctr"/>
+          <a:lstStyle/>
+          <a:p>
+            <a:pPr algn="ctr"/>
+          </a:p>
+        </p:txBody>
+      </p:sp>
+      <p:pic>
+        <p:nvPicPr>
+          <p:cNvPr id="22" name="Picture 21" descr="logo-mm.png"/>
+          <p:cNvPicPr>
+            <a:picLocks noChangeAspect="1"/>
+          </p:cNvPicPr>
+          <p:nvPr/>
+        </p:nvPicPr>
+        <p:blipFill>
+          <a:blip r:embed="rId10"/>
+          <a:stretch>
+            <a:fillRect/>
+          </a:stretch>
+        </p:blipFill>
+        <p:spPr>
+          <a:xfrm>
+            <a:off x="8366760" y="4828032"/>
+            <a:ext cx="1020938" cy="640080"/>
+          </a:xfrm>
+          <a:prstGeom prst="rect">
+            <a:avLst/>
+          </a:prstGeom>
+        </p:spPr>
+      </p:pic>
     </p:spTree>
   </p:cSld>
   <p:clrMapOvr>

</xml_diff>